<commit_message>
Add team member names and SRNs to README, write-up and slides
</commit_message>
<xml_diff>
--- a/docs/Slides_Link_Failure_Prediction.pptx
+++ b/docs/Slides_Link_Failure_Prediction.pptx
@@ -5033,7 +5033,7 @@
                 </a:solidFill>
                 <a:latin typeface="Calibri"/>
               </a:rPr>
-              <a:t>Team: Member 1 (SRN)  ·  Member 2 (SRN)</a:t>
+              <a:t>Team: J Sanjay Varma (PES1UG24CS194)  ·  Kanak Pandey (PES1UG24CS212)</a:t>
             </a:r>
           </a:p>
         </p:txBody>
@@ -6972,7 +6972,7 @@
                 </a:solidFill>
                 <a:latin typeface="Calibri"/>
               </a:rPr>
-              <a:t>Member 1 — simulator, preprocessing, localisation, demo · Member 2 — models, evaluation, extensions, report</a:t>
+              <a:t>J Sanjay Varma — simulator, preprocessing, localisation, demo · Kanak Pandey — models, evaluation, extensions, report</a:t>
             </a:r>
           </a:p>
         </p:txBody>

</xml_diff>